<commit_message>
Move Executive Command Center to the final training exercise
Renumber exercises and update the workshop documents, decks, and artwork. Keep the screenshot-based cost review in the new first exercise, Deep Research.

Co-authored-by: Copilot <223556219+Copilot@users.noreply.github.com>
</commit_message>
<xml_diff>
--- a/instructor/customer-preview-deck.pptx
+++ b/instructor/customer-preview-deck.pptx
@@ -1358,7 +1358,7 @@
           <a:lstStyle/>
           <a:p>
             <a:r>
-              <a:t>THREE TOOLS. Cowork is the focus (7 of 8 exercises). The finale is deliberately NOT Cowork: Agent Builder, so attendees leave knowing the difference between a skill that helps them and an agent that helps others.</a:t>
+              <a:t>THREE TOOLS. Cowork is the focus (7 of 8 exercises). Exercise 7 deliberately uses Agent Builder, then Exercise 8 returns to Cowork for the Executive Command Center capstone. Attendees leave knowing the difference between a skill that helps them and an agent that helps others.</a:t>
             </a:r>
           </a:p>
         </p:txBody>
@@ -1568,7 +1568,7 @@
           <a:lstStyle/>
           <a:p>
             <a:r>
-              <a:t>EXERCISES. For each card, give one sentence on the HR value. ASK: which of these would your team use next week? Which would you drop or swap for one of your own HR scenarios? Exercise 8 is deliberately NOT Cowork: it's Copilot Agent Builder.</a:t>
+              <a:t>EXERCISES. For each card, give one sentence on the HR value. ASK: which of these would your team use next week? Which would you drop or swap for one of your own HR scenarios? Exercise 7 is deliberately NOT Cowork: it's Copilot Agent Builder.</a:t>
             </a:r>
           </a:p>
         </p:txBody>
@@ -5669,7 +5669,7 @@
                 </a:solidFill>
                 <a:latin typeface="Segoe UI"/>
               </a:rPr>
-              <a:t>Exercises 2–8 use the fictional company Zava. Exercise 1 runs privately on each attendee’s own work.</a:t>
+              <a:t>Exercises 1–7 use the fictional company Zava. Exercise 8 runs privately on each attendee’s own work.</a:t>
             </a:r>
           </a:p>
         </p:txBody>
@@ -8643,7 +8643,7 @@
                 </a:solidFill>
                 <a:latin typeface="Segoe UI"/>
               </a:rPr>
-              <a:t> allowed for the group (Exercise 3)</a:t>
+              <a:t> allowed for the group (Exercise 2)</a:t>
             </a:r>
           </a:p>
           <a:p>
@@ -12815,7 +12815,7 @@
                 </a:solidFill>
                 <a:latin typeface="Segoe UI"/>
               </a:rPr>
-              <a:t>Extend Exercise 8, or plan a follow-up on Copilot Studio.</a:t>
+              <a:t>Extend Exercise 7, or plan a follow-up on Copilot Studio.</a:t>
             </a:r>
           </a:p>
         </p:txBody>
@@ -17681,7 +17681,7 @@
                 </a:solidFill>
                 <a:latin typeface="Segoe UI"/>
               </a:rPr>
-              <a:t> (the company “Zava”); Exercise 1 uses each attendee’s own work, privately</a:t>
+              <a:t> (the company “Zava”); Exercise 8 uses each attendee’s own work, privately</a:t>
             </a:r>
           </a:p>
           <a:p>
@@ -20020,7 +20020,7 @@
         <p:spPr>
           <a:xfrm>
             <a:off x="4553712" y="4389120"/>
-            <a:ext cx="1206384" cy="292608"/>
+            <a:ext cx="1636568" cy="292608"/>
           </a:xfrm>
           <a:prstGeom prst="roundRect">
             <a:avLst>
@@ -20066,7 +20066,7 @@
         <p:spPr>
           <a:xfrm>
             <a:off x="4553712" y="4389120"/>
-            <a:ext cx="1206384" cy="292608"/>
+            <a:ext cx="1636568" cy="292608"/>
           </a:xfrm>
           <a:prstGeom prst="rect">
             <a:avLst/>
@@ -20091,7 +20091,7 @@
                 </a:solidFill>
                 <a:latin typeface="Segoe Sans Display Semibold"/>
               </a:rPr>
-              <a:t>Exercises 1–7</a:t>
+              <a:t>Exercises 1–6 and 8</a:t>
             </a:r>
           </a:p>
         </p:txBody>
@@ -20404,7 +20404,7 @@
                 </a:solidFill>
                 <a:latin typeface="Segoe Sans Display Semibold"/>
               </a:rPr>
-              <a:t>Exercise 8 (not Cowork)</a:t>
+              <a:t>Exercise 7 (not Cowork)</a:t>
             </a:r>
           </a:p>
         </p:txBody>
@@ -20504,7 +20504,7 @@
                 </a:solidFill>
                 <a:latin typeface="Segoe Sans Display"/>
               </a:rPr>
-              <a:t> (Exercises 1–7). The finale switches to </a:t>
+              <a:t> (Exercises 1–6 and 8). Exercise 7 switches to </a:t>
             </a:r>
             <a:r>
               <a:rPr sz="1500" b="1" i="0">
@@ -20514,6 +20514,24 @@
                 <a:latin typeface="Segoe Sans Display Semibold"/>
               </a:rPr>
               <a:t>Agent Builder</a:t>
+            </a:r>
+            <a:r>
+              <a:rPr sz="1500" b="0" i="0">
+                <a:solidFill>
+                  <a:srgbClr val="FFFFFF"/>
+                </a:solidFill>
+                <a:latin typeface="Segoe Sans Display"/>
+              </a:rPr>
+              <a:t>; the finale returns to </a:t>
+            </a:r>
+            <a:r>
+              <a:rPr sz="1500" b="1" i="0">
+                <a:solidFill>
+                  <a:srgbClr val="FFFFFF"/>
+                </a:solidFill>
+                <a:latin typeface="Segoe Sans Display Semibold"/>
+              </a:rPr>
+              <a:t>Cowork</a:t>
             </a:r>
             <a:r>
               <a:rPr sz="1500" b="0" i="0">
@@ -21075,7 +21093,7 @@
                 </a:solidFill>
                 <a:latin typeface="Segoe UI"/>
               </a:rPr>
-              <a:t>Ex 1 · Executive Command Center</a:t>
+              <a:t>Ex 1 · Research the Web with Deep Research</a:t>
             </a:r>
           </a:p>
         </p:txBody>
@@ -21207,7 +21225,7 @@
                 </a:solidFill>
                 <a:latin typeface="Segoe UI"/>
               </a:rPr>
-              <a:t>Ex 2 · Research the Web with Deep Research</a:t>
+              <a:t>Ex 2 · Navigate Websites with Cowork’s Browser</a:t>
             </a:r>
           </a:p>
         </p:txBody>
@@ -21339,7 +21357,7 @@
                 </a:solidFill>
                 <a:latin typeface="Segoe UI"/>
               </a:rPr>
-              <a:t>Ex 3 · Navigate Websites with Cowork’s Browser</a:t>
+              <a:t>Ex 3 · Build a Custom Skill: HR Policy Answer</a:t>
             </a:r>
           </a:p>
         </p:txBody>
@@ -21432,7 +21450,7 @@
                 </a:solidFill>
                 <a:latin typeface="Segoe Sans Display Semibold"/>
               </a:rPr>
-              <a:t>1:05–1:20</a:t>
+              <a:t>1:05–1:15</a:t>
             </a:r>
           </a:p>
         </p:txBody>
@@ -21471,7 +21489,7 @@
                 </a:solidFill>
                 <a:latin typeface="Segoe UI"/>
               </a:rPr>
-              <a:t>Ex 4 · Build a Custom Skill: HR Policy Answer</a:t>
+              <a:t>Ex 4 · Recruiting + Reporting</a:t>
             </a:r>
           </a:p>
         </p:txBody>
@@ -21491,6 +21509,138 @@
         <p:spPr>
           <a:xfrm>
             <a:off x="548640" y="4846320"/>
+            <a:ext cx="5394960" cy="512064"/>
+          </a:xfrm>
+          <a:prstGeom prst="roundRect">
+            <a:avLst>
+              <a:gd name="adj" fmla="val 20000"/>
+            </a:avLst>
+          </a:prstGeom>
+          <a:solidFill>
+            <a:srgbClr val="F4F4F4"/>
+          </a:solidFill>
+          <a:ln w="9525">
+            <a:solidFill>
+              <a:srgbClr val="D1D1D1"/>
+            </a:solidFill>
+          </a:ln>
+          <a:effectLst/>
+        </p:spPr>
+        <p:style>
+          <a:lnRef idx="1">
+            <a:schemeClr val="accent1"/>
+          </a:lnRef>
+          <a:fillRef idx="3">
+            <a:schemeClr val="accent1"/>
+          </a:fillRef>
+          <a:effectRef idx="2">
+            <a:schemeClr val="accent1"/>
+          </a:effectRef>
+          <a:fontRef idx="minor">
+            <a:schemeClr val="lt1"/>
+          </a:fontRef>
+        </p:style>
+        <p:txBody>
+          <a:bodyPr rtlCol="0" anchor="ctr"/>
+          <a:lstStyle/>
+          <a:p>
+            <a:pPr algn="ctr"/>
+          </a:p>
+        </p:txBody>
+      </p:sp>
+      <p:sp>
+        <p:nvSpPr>
+          <p:cNvPr id="25" name="TextBox 24"/>
+          <p:cNvSpPr txBox="1"/>
+          <p:nvPr/>
+        </p:nvSpPr>
+        <p:spPr>
+          <a:xfrm>
+            <a:off x="731520" y="4846320"/>
+            <a:ext cx="1188720" cy="512064"/>
+          </a:xfrm>
+          <a:prstGeom prst="rect">
+            <a:avLst/>
+          </a:prstGeom>
+          <a:noFill/>
+        </p:spPr>
+        <p:txBody>
+          <a:bodyPr wrap="square" anchor="ctr" lIns="0" rIns="0" tIns="0" bIns="0">
+            <a:spAutoFit/>
+          </a:bodyPr>
+          <a:lstStyle/>
+          <a:p>
+            <a:pPr algn="l">
+              <a:spcAft>
+                <a:spcPts val="400"/>
+              </a:spcAft>
+            </a:pPr>
+            <a:r>
+              <a:rPr sz="1200" b="1" i="0">
+                <a:solidFill>
+                  <a:srgbClr val="8064A2"/>
+                </a:solidFill>
+                <a:latin typeface="Segoe Sans Display Semibold"/>
+              </a:rPr>
+              <a:t>1:15–1:30</a:t>
+            </a:r>
+          </a:p>
+        </p:txBody>
+      </p:sp>
+      <p:sp>
+        <p:nvSpPr>
+          <p:cNvPr id="26" name="TextBox 25"/>
+          <p:cNvSpPr txBox="1"/>
+          <p:nvPr/>
+        </p:nvSpPr>
+        <p:spPr>
+          <a:xfrm>
+            <a:off x="1920240" y="4846320"/>
+            <a:ext cx="3931920" cy="512064"/>
+          </a:xfrm>
+          <a:prstGeom prst="rect">
+            <a:avLst/>
+          </a:prstGeom>
+          <a:noFill/>
+        </p:spPr>
+        <p:txBody>
+          <a:bodyPr wrap="square" anchor="ctr" lIns="0" rIns="0" tIns="0" bIns="0">
+            <a:spAutoFit/>
+          </a:bodyPr>
+          <a:lstStyle/>
+          <a:p>
+            <a:pPr algn="l">
+              <a:spcAft>
+                <a:spcPts val="400"/>
+              </a:spcAft>
+            </a:pPr>
+            <a:r>
+              <a:rPr sz="1250" b="0" i="0">
+                <a:solidFill>
+                  <a:srgbClr val="616161"/>
+                </a:solidFill>
+                <a:latin typeface="Segoe UI"/>
+              </a:rPr>
+              <a:t>Break</a:t>
+            </a:r>
+          </a:p>
+        </p:txBody>
+      </p:sp>
+      <p:sp>
+        <p:nvSpPr>
+          <p:cNvPr id="27" name="Rounded Rectangle 26">
+            <a:extLst>
+              <a:ext uri="{C183D7F6-B498-43B3-948B-1728B52AA6E4}">
+                <ns8:decorative xmlns:ns8="http://schemas.microsoft.com/office/drawing/2017/decorative" val="1"/>
+              </a:ext>
+            </a:extLst>
+          </p:cNvPr>
+          <p:cNvSpPr/>
+          <p:nvPr/>
+        </p:nvSpPr>
+        <p:spPr>
+          <a:xfrm>
+            <a:off x="6217920" y="1828800"/>
             <a:ext cx="5394960" cy="512064"/>
           </a:xfrm>
           <a:prstGeom prst="roundRect">
@@ -21532,13 +21682,13 @@
       </p:sp>
       <p:sp>
         <p:nvSpPr>
-          <p:cNvPr id="25" name="TextBox 24"/>
+          <p:cNvPr id="28" name="TextBox 27"/>
           <p:cNvSpPr txBox="1"/>
           <p:nvPr/>
         </p:nvSpPr>
         <p:spPr>
           <a:xfrm>
-            <a:off x="731520" y="4846320"/>
+            <a:off x="6400800" y="1828800"/>
             <a:ext cx="1188720" cy="512064"/>
           </a:xfrm>
           <a:prstGeom prst="rect">
@@ -21564,20 +21714,20 @@
                 </a:solidFill>
                 <a:latin typeface="Segoe Sans Display Semibold"/>
               </a:rPr>
-              <a:t>1:20–1:30</a:t>
-            </a:r>
-          </a:p>
-        </p:txBody>
-      </p:sp>
-      <p:sp>
-        <p:nvSpPr>
-          <p:cNvPr id="26" name="TextBox 25"/>
+              <a:t>1:30–1:40</a:t>
+            </a:r>
+          </a:p>
+        </p:txBody>
+      </p:sp>
+      <p:sp>
+        <p:nvSpPr>
+          <p:cNvPr id="29" name="TextBox 28"/>
           <p:cNvSpPr txBox="1"/>
           <p:nvPr/>
         </p:nvSpPr>
         <p:spPr>
           <a:xfrm>
-            <a:off x="1920240" y="4846320"/>
+            <a:off x="7589520" y="1828800"/>
             <a:ext cx="3931920" cy="512064"/>
           </a:xfrm>
           <a:prstGeom prst="rect">
@@ -21603,139 +21753,7 @@
                 </a:solidFill>
                 <a:latin typeface="Segoe UI"/>
               </a:rPr>
-              <a:t>Ex 5 · Recruiting + Reporting</a:t>
-            </a:r>
-          </a:p>
-        </p:txBody>
-      </p:sp>
-      <p:sp>
-        <p:nvSpPr>
-          <p:cNvPr id="27" name="Rounded Rectangle 26">
-            <a:extLst>
-              <a:ext uri="{C183D7F6-B498-43B3-948B-1728B52AA6E4}">
-                <ns8:decorative xmlns:ns8="http://schemas.microsoft.com/office/drawing/2017/decorative" val="1"/>
-              </a:ext>
-            </a:extLst>
-          </p:cNvPr>
-          <p:cNvSpPr/>
-          <p:nvPr/>
-        </p:nvSpPr>
-        <p:spPr>
-          <a:xfrm>
-            <a:off x="6217920" y="1828800"/>
-            <a:ext cx="5394960" cy="512064"/>
-          </a:xfrm>
-          <a:prstGeom prst="roundRect">
-            <a:avLst>
-              <a:gd name="adj" fmla="val 20000"/>
-            </a:avLst>
-          </a:prstGeom>
-          <a:solidFill>
-            <a:srgbClr val="F4F4F4"/>
-          </a:solidFill>
-          <a:ln w="9525">
-            <a:solidFill>
-              <a:srgbClr val="D1D1D1"/>
-            </a:solidFill>
-          </a:ln>
-          <a:effectLst/>
-        </p:spPr>
-        <p:style>
-          <a:lnRef idx="1">
-            <a:schemeClr val="accent1"/>
-          </a:lnRef>
-          <a:fillRef idx="3">
-            <a:schemeClr val="accent1"/>
-          </a:fillRef>
-          <a:effectRef idx="2">
-            <a:schemeClr val="accent1"/>
-          </a:effectRef>
-          <a:fontRef idx="minor">
-            <a:schemeClr val="lt1"/>
-          </a:fontRef>
-        </p:style>
-        <p:txBody>
-          <a:bodyPr rtlCol="0" anchor="ctr"/>
-          <a:lstStyle/>
-          <a:p>
-            <a:pPr algn="ctr"/>
-          </a:p>
-        </p:txBody>
-      </p:sp>
-      <p:sp>
-        <p:nvSpPr>
-          <p:cNvPr id="28" name="TextBox 27"/>
-          <p:cNvSpPr txBox="1"/>
-          <p:nvPr/>
-        </p:nvSpPr>
-        <p:spPr>
-          <a:xfrm>
-            <a:off x="6400800" y="1828800"/>
-            <a:ext cx="1188720" cy="512064"/>
-          </a:xfrm>
-          <a:prstGeom prst="rect">
-            <a:avLst/>
-          </a:prstGeom>
-          <a:noFill/>
-        </p:spPr>
-        <p:txBody>
-          <a:bodyPr wrap="square" anchor="ctr" lIns="0" rIns="0" tIns="0" bIns="0">
-            <a:spAutoFit/>
-          </a:bodyPr>
-          <a:lstStyle/>
-          <a:p>
-            <a:pPr algn="l">
-              <a:spcAft>
-                <a:spcPts val="400"/>
-              </a:spcAft>
-            </a:pPr>
-            <a:r>
-              <a:rPr sz="1200" b="1" i="0">
-                <a:solidFill>
-                  <a:srgbClr val="8064A2"/>
-                </a:solidFill>
-                <a:latin typeface="Segoe Sans Display Semibold"/>
-              </a:rPr>
-              <a:t>1:30–1:45</a:t>
-            </a:r>
-          </a:p>
-        </p:txBody>
-      </p:sp>
-      <p:sp>
-        <p:nvSpPr>
-          <p:cNvPr id="29" name="TextBox 28"/>
-          <p:cNvSpPr txBox="1"/>
-          <p:nvPr/>
-        </p:nvSpPr>
-        <p:spPr>
-          <a:xfrm>
-            <a:off x="7589520" y="1828800"/>
-            <a:ext cx="3931920" cy="512064"/>
-          </a:xfrm>
-          <a:prstGeom prst="rect">
-            <a:avLst/>
-          </a:prstGeom>
-          <a:noFill/>
-        </p:spPr>
-        <p:txBody>
-          <a:bodyPr wrap="square" anchor="ctr" lIns="0" rIns="0" tIns="0" bIns="0">
-            <a:spAutoFit/>
-          </a:bodyPr>
-          <a:lstStyle/>
-          <a:p>
-            <a:pPr algn="l">
-              <a:spcAft>
-                <a:spcPts val="400"/>
-              </a:spcAft>
-            </a:pPr>
-            <a:r>
-              <a:rPr sz="1250" b="0" i="0">
-                <a:solidFill>
-                  <a:srgbClr val="616161"/>
-                </a:solidFill>
-                <a:latin typeface="Segoe UI"/>
-              </a:rPr>
-              <a:t>Break</a:t>
+              <a:t>Ex 5 · Onboarding Orientation Pack</a:t>
             </a:r>
           </a:p>
         </p:txBody>
@@ -21828,7 +21846,7 @@
                 </a:solidFill>
                 <a:latin typeface="Segoe Sans Display Semibold"/>
               </a:rPr>
-              <a:t>1:45–1:55</a:t>
+              <a:t>1:40–1:55</a:t>
             </a:r>
           </a:p>
         </p:txBody>
@@ -21867,7 +21885,7 @@
                 </a:solidFill>
                 <a:latin typeface="Segoe UI"/>
               </a:rPr>
-              <a:t>Ex 6 · Onboarding Orientation Pack</a:t>
+              <a:t>Ex 6 · Automate &amp; Share</a:t>
             </a:r>
           </a:p>
         </p:txBody>
@@ -21999,7 +22017,7 @@
                 </a:solidFill>
                 <a:latin typeface="Segoe UI"/>
               </a:rPr>
-              <a:t>Ex 7 · Automate &amp; Share</a:t>
+              <a:t>Ex 7 · HR Policy Agent with Agent Builder (not Cowork)</a:t>
             </a:r>
           </a:p>
         </p:txBody>
@@ -22131,7 +22149,7 @@
                 </a:solidFill>
                 <a:latin typeface="Segoe UI"/>
               </a:rPr>
-              <a:t>Ex 8 · HR Policy Agent with Agent Builder (not Cowork)</a:t>
+              <a:t>Ex 8 · Executive Command Center</a:t>
             </a:r>
           </a:p>
         </p:txBody>
@@ -22763,7 +22781,7 @@
                 </a:solidFill>
                 <a:latin typeface="Segoe Sans Display Semibold"/>
               </a:rPr>
-              <a:t>Executive Command Center</a:t>
+              <a:t>Research the Web with Deep Research</a:t>
             </a:r>
           </a:p>
         </p:txBody>
@@ -22805,7 +22823,7 @@
                 </a:solidFill>
                 <a:latin typeface="Segoe UI"/>
               </a:rPr>
-              <a:t>Turn your calendar, communications, and priority work into a daily executive view of decisions, risks, and actions requiring attention.</a:t>
+              <a:t>Get an evidence-based view of structured behavioral interviewing and turn it into questions for a real open role.</a:t>
             </a:r>
           </a:p>
           <a:p>
@@ -22833,7 +22851,7 @@
                 </a:solidFill>
                 <a:latin typeface="Segoe UI"/>
               </a:rPr>
-              <a:t> An interactive executive command center covering meetings, priorities, and org pulse, with labeled recommendations and links to supporting context.</a:t>
+              <a:t> A cited one-page briefing and five tailored questions for Zava’s HR Coordinator role; if time allows, an interviewer scorecard in Word and Excel with the scoring scales filled in.</a:t>
             </a:r>
           </a:p>
         </p:txBody>
@@ -22944,7 +22962,7 @@
         <p:spPr>
           <a:xfrm>
             <a:off x="1489640" y="5806440"/>
-            <a:ext cx="835429" cy="274320"/>
+            <a:ext cx="960120" cy="274320"/>
           </a:xfrm>
           <a:prstGeom prst="roundRect">
             <a:avLst>
@@ -22990,7 +23008,7 @@
         <p:spPr>
           <a:xfrm>
             <a:off x="1489640" y="5806440"/>
-            <a:ext cx="835429" cy="274320"/>
+            <a:ext cx="960120" cy="274320"/>
           </a:xfrm>
           <a:prstGeom prst="rect">
             <a:avLst/>
@@ -23015,7 +23033,7 @@
                 </a:solidFill>
                 <a:latin typeface="Segoe Sans Display Semibold"/>
               </a:rPr>
-              <a:t>Executive</a:t>
+              <a:t>HR · Talent</a:t>
             </a:r>
           </a:p>
         </p:txBody>
@@ -23226,7 +23244,7 @@
                 </a:solidFill>
                 <a:latin typeface="Segoe Sans Display Semibold"/>
               </a:rPr>
-              <a:t>Research the Web with Deep Research</a:t>
+              <a:t>Navigate Websites with Cowork’s Browser</a:t>
             </a:r>
           </a:p>
         </p:txBody>
@@ -23268,7 +23286,7 @@
                 </a:solidFill>
                 <a:latin typeface="Segoe UI"/>
               </a:rPr>
-              <a:t>Get an evidence-based view of structured behavioral interviewing and turn it into questions for a real open role.</a:t>
+              <a:t>Have Cowork drive a real web browser for you — search a site, click through, move to a second site — and bring back a sourced comparison.</a:t>
             </a:r>
           </a:p>
           <a:p>
@@ -23296,7 +23314,7 @@
                 </a:solidFill>
                 <a:latin typeface="Segoe UI"/>
               </a:rPr>
-              <a:t> A cited one-page briefing and five tailored questions for Zava’s HR Coordinator role; if time allows, an interviewer scorecard in Word and Excel with the scoring scales filled in.</a:t>
+              <a:t> An overtime comparison (U.S. DOL vs. Washington L&amp;I vs. Zava handbook) with a link to every page visited; if time allows, a one-page Word brief for payroll about T-2008.</a:t>
             </a:r>
           </a:p>
         </p:txBody>
@@ -23407,7 +23425,7 @@
         <p:spPr>
           <a:xfrm>
             <a:off x="4303249" y="5806440"/>
-            <a:ext cx="960120" cy="274320"/>
+            <a:ext cx="1209501" cy="274320"/>
           </a:xfrm>
           <a:prstGeom prst="roundRect">
             <a:avLst>
@@ -23453,7 +23471,7 @@
         <p:spPr>
           <a:xfrm>
             <a:off x="4303249" y="5806440"/>
-            <a:ext cx="960120" cy="274320"/>
+            <a:ext cx="1209501" cy="274320"/>
           </a:xfrm>
           <a:prstGeom prst="rect">
             <a:avLst/>
@@ -23478,7 +23496,7 @@
                 </a:solidFill>
                 <a:latin typeface="Segoe Sans Display Semibold"/>
               </a:rPr>
-              <a:t>HR · Talent</a:t>
+              <a:t>HR · Compliance</a:t>
             </a:r>
           </a:p>
         </p:txBody>
@@ -23689,7 +23707,7 @@
                 </a:solidFill>
                 <a:latin typeface="Segoe Sans Display Semibold"/>
               </a:rPr>
-              <a:t>Navigate Websites with Cowork’s Browser</a:t>
+              <a:t>Build a Custom Skill: HR Policy Answer</a:t>
             </a:r>
           </a:p>
         </p:txBody>
@@ -23731,7 +23749,7 @@
                 </a:solidFill>
                 <a:latin typeface="Segoe UI"/>
               </a:rPr>
-              <a:t>Have Cowork drive a real web browser for you — search a site, click through, move to a second site — and bring back a sourced comparison.</a:t>
+              <a:t>Teach Cowork to answer policy and benefits questions the same clear, sourced way — every time.</a:t>
             </a:r>
           </a:p>
           <a:p>
@@ -23759,7 +23777,7 @@
                 </a:solidFill>
                 <a:latin typeface="Segoe UI"/>
               </a:rPr>
-              <a:t> An overtime comparison (U.S. DOL vs. Washington L&amp;I vs. Zava handbook) with a link to every page visited; if time allows, a one-page Word brief for payroll about T-2008.</a:t>
+              <a:t> A saved custom skill, “HR Policy Answer,” with a quality score, that triggers on policy questions and answers Answer → Details → Source → “confirm with HR.”</a:t>
             </a:r>
           </a:p>
         </p:txBody>
@@ -23870,7 +23888,7 @@
         <p:spPr>
           <a:xfrm>
             <a:off x="7116858" y="5806440"/>
-            <a:ext cx="1209501" cy="274320"/>
+            <a:ext cx="960120" cy="274320"/>
           </a:xfrm>
           <a:prstGeom prst="roundRect">
             <a:avLst>
@@ -23916,7 +23934,7 @@
         <p:spPr>
           <a:xfrm>
             <a:off x="7116858" y="5806440"/>
-            <a:ext cx="1209501" cy="274320"/>
+            <a:ext cx="960120" cy="274320"/>
           </a:xfrm>
           <a:prstGeom prst="rect">
             <a:avLst/>
@@ -23941,7 +23959,7 @@
                 </a:solidFill>
                 <a:latin typeface="Segoe Sans Display Semibold"/>
               </a:rPr>
-              <a:t>HR · Compliance</a:t>
+              <a:t>HR · Policy</a:t>
             </a:r>
           </a:p>
         </p:txBody>
@@ -24152,7 +24170,7 @@
                 </a:solidFill>
                 <a:latin typeface="Segoe Sans Display Semibold"/>
               </a:rPr>
-              <a:t>Build a Custom Skill: HR Policy Answer</a:t>
+              <a:t>Recruiting + Reporting</a:t>
             </a:r>
           </a:p>
         </p:txBody>
@@ -24194,7 +24212,7 @@
                 </a:solidFill>
                 <a:latin typeface="Segoe UI"/>
               </a:rPr>
-              <a:t>Teach Cowork to answer policy and benefits questions the same clear, sourced way — every time.</a:t>
+              <a:t>Attract the right candidates for an open role and get on top of the HR service queue in minutes.</a:t>
             </a:r>
           </a:p>
           <a:p>
@@ -24222,7 +24240,7 @@
                 </a:solidFill>
                 <a:latin typeface="Segoe UI"/>
               </a:rPr>
-              <a:t> A saved custom skill, “HR Policy Answer,” with a quality score, that triggers on policy questions and answers Answer → Details → Source → “confirm with HR.”</a:t>
+              <a:t> An inclusive HR Coordinator job posting in Word, with off-putting wording flagged, and a ticket summary highlighting today’s high-priority open items.</a:t>
             </a:r>
           </a:p>
         </p:txBody>
@@ -24313,7 +24331,7 @@
                 </a:solidFill>
                 <a:latin typeface="Segoe Sans Display Semibold"/>
               </a:rPr>
-              <a:t>15 min</a:t>
+              <a:t>10 min</a:t>
             </a:r>
           </a:p>
         </p:txBody>
@@ -24333,7 +24351,7 @@
         <p:spPr>
           <a:xfrm>
             <a:off x="9930467" y="5806440"/>
-            <a:ext cx="960120" cy="274320"/>
+            <a:ext cx="1334192" cy="274320"/>
           </a:xfrm>
           <a:prstGeom prst="roundRect">
             <a:avLst>
@@ -24379,7 +24397,7 @@
         <p:spPr>
           <a:xfrm>
             <a:off x="9930467" y="5806440"/>
-            <a:ext cx="960120" cy="274320"/>
+            <a:ext cx="1334192" cy="274320"/>
           </a:xfrm>
           <a:prstGeom prst="rect">
             <a:avLst/>
@@ -24404,7 +24422,7 @@
                 </a:solidFill>
                 <a:latin typeface="Segoe Sans Display Semibold"/>
               </a:rPr>
-              <a:t>HR · Policy</a:t>
+              <a:t>HR · Talent &amp; Ops</a:t>
             </a:r>
           </a:p>
         </p:txBody>
@@ -24904,7 +24922,7 @@
                 </a:solidFill>
                 <a:latin typeface="Segoe Sans Display Semibold"/>
               </a:rPr>
-              <a:t>Recruiting + Reporting</a:t>
+              <a:t>Onboarding Orientation Pack</a:t>
             </a:r>
           </a:p>
         </p:txBody>
@@ -24946,7 +24964,7 @@
                 </a:solidFill>
                 <a:latin typeface="Segoe UI"/>
               </a:rPr>
-              <a:t>Attract the right candidates for an open role and get on top of the HR service queue in minutes.</a:t>
+              <a:t>Give a new hire a polished first-day experience without assembling it by hand.</a:t>
             </a:r>
           </a:p>
           <a:p>
@@ -24974,7 +24992,7 @@
                 </a:solidFill>
                 <a:latin typeface="Segoe UI"/>
               </a:rPr>
-              <a:t> An inclusive HR Coordinator job posting in Word, with off-putting wording flagged, and a ticket summary highlighting today’s high-priority open items.</a:t>
+              <a:t> A 6–8 slide orientation deck for Sofia Alvarez, Zava’s new HR Coordinator; if time allows, a scheduled kickoff with a Teams link and a team announcement draft.</a:t>
             </a:r>
           </a:p>
         </p:txBody>
@@ -25085,7 +25103,7 @@
         <p:spPr>
           <a:xfrm>
             <a:off x="1489640" y="5806440"/>
-            <a:ext cx="1334192" cy="274320"/>
+            <a:ext cx="1209501" cy="274320"/>
           </a:xfrm>
           <a:prstGeom prst="roundRect">
             <a:avLst>
@@ -25131,7 +25149,7 @@
         <p:spPr>
           <a:xfrm>
             <a:off x="1489640" y="5806440"/>
-            <a:ext cx="1334192" cy="274320"/>
+            <a:ext cx="1209501" cy="274320"/>
           </a:xfrm>
           <a:prstGeom prst="rect">
             <a:avLst/>
@@ -25156,7 +25174,7 @@
                 </a:solidFill>
                 <a:latin typeface="Segoe Sans Display Semibold"/>
               </a:rPr>
-              <a:t>HR · Talent &amp; Ops</a:t>
+              <a:t>HR · Onboarding</a:t>
             </a:r>
           </a:p>
         </p:txBody>
@@ -25367,7 +25385,7 @@
                 </a:solidFill>
                 <a:latin typeface="Segoe Sans Display Semibold"/>
               </a:rPr>
-              <a:t>Onboarding Orientation Pack</a:t>
+              <a:t>Automate &amp; Share</a:t>
             </a:r>
           </a:p>
         </p:txBody>
@@ -25409,7 +25427,7 @@
                 </a:solidFill>
                 <a:latin typeface="Segoe UI"/>
               </a:rPr>
-              <a:t>Give a new hire a polished first-day experience without assembling it by hand.</a:t>
+              <a:t>Stop re-asking for the same work — put it on a schedule and share what you built.</a:t>
             </a:r>
           </a:p>
           <a:p>
@@ -25437,7 +25455,7 @@
                 </a:solidFill>
                 <a:latin typeface="Segoe UI"/>
               </a:rPr>
-              <a:t> A 6–8 slide orientation deck for Sofia Alvarez, Zava’s new HR Coordinator; if time allows, a scheduled kickoff with a Teams link and a team announcement draft.</a:t>
+              <a:t> An active weekly automation (Monday HR-ticket digest) and a Daily Briefing; if time allows, your custom skill shared (or kept private) and re-shared after an edit.</a:t>
             </a:r>
           </a:p>
         </p:txBody>
@@ -25528,7 +25546,7 @@
                 </a:solidFill>
                 <a:latin typeface="Segoe Sans Display Semibold"/>
               </a:rPr>
-              <a:t>10 min</a:t>
+              <a:t>15 min</a:t>
             </a:r>
           </a:p>
         </p:txBody>
@@ -25619,7 +25637,7 @@
                 </a:solidFill>
                 <a:latin typeface="Segoe Sans Display Semibold"/>
               </a:rPr>
-              <a:t>HR · Onboarding</a:t>
+              <a:t>HR · Operations</a:t>
             </a:r>
           </a:p>
         </p:txBody>
@@ -25639,6 +25657,560 @@
         <p:spPr>
           <a:xfrm>
             <a:off x="6175857" y="1783080"/>
+            <a:ext cx="2651760" cy="4480560"/>
+          </a:xfrm>
+          <a:prstGeom prst="roundRect">
+            <a:avLst>
+              <a:gd name="adj" fmla="val 5000"/>
+            </a:avLst>
+          </a:prstGeom>
+          <a:solidFill>
+            <a:srgbClr val="FFFFFF"/>
+          </a:solidFill>
+          <a:ln w="9525">
+            <a:solidFill>
+              <a:srgbClr val="C0504D"/>
+            </a:solidFill>
+          </a:ln>
+          <a:effectLst/>
+        </p:spPr>
+        <p:style>
+          <a:lnRef idx="1">
+            <a:schemeClr val="accent1"/>
+          </a:lnRef>
+          <a:fillRef idx="3">
+            <a:schemeClr val="accent1"/>
+          </a:fillRef>
+          <a:effectRef idx="2">
+            <a:schemeClr val="accent1"/>
+          </a:effectRef>
+          <a:fontRef idx="minor">
+            <a:schemeClr val="lt1"/>
+          </a:fontRef>
+        </p:style>
+        <p:txBody>
+          <a:bodyPr rtlCol="0" anchor="ctr"/>
+          <a:lstStyle/>
+          <a:p>
+            <a:pPr algn="ctr"/>
+          </a:p>
+        </p:txBody>
+      </p:sp>
+      <p:sp>
+        <p:nvSpPr>
+          <p:cNvPr id="30" name="Oval 29">
+            <a:extLst>
+              <a:ext uri="{C183D7F6-B498-43B3-948B-1728B52AA6E4}">
+                <ns11:decorative xmlns:ns11="http://schemas.microsoft.com/office/drawing/2017/decorative" val="1"/>
+              </a:ext>
+            </a:extLst>
+          </p:cNvPr>
+          <p:cNvSpPr/>
+          <p:nvPr/>
+        </p:nvSpPr>
+        <p:spPr>
+          <a:xfrm>
+            <a:off x="7044537" y="1965960"/>
+            <a:ext cx="914400" cy="914400"/>
+          </a:xfrm>
+          <a:prstGeom prst="ellipse">
+            <a:avLst/>
+          </a:prstGeom>
+          <a:solidFill>
+            <a:srgbClr val="FFF9FD"/>
+          </a:solidFill>
+          <a:ln w="9525">
+            <a:solidFill>
+              <a:srgbClr val="D1D1D1"/>
+            </a:solidFill>
+          </a:ln>
+          <a:effectLst/>
+        </p:spPr>
+        <p:style>
+          <a:lnRef idx="1">
+            <a:schemeClr val="accent1"/>
+          </a:lnRef>
+          <a:fillRef idx="3">
+            <a:schemeClr val="accent1"/>
+          </a:fillRef>
+          <a:effectRef idx="2">
+            <a:schemeClr val="accent1"/>
+          </a:effectRef>
+          <a:fontRef idx="minor">
+            <a:schemeClr val="lt1"/>
+          </a:fontRef>
+        </p:style>
+        <p:txBody>
+          <a:bodyPr rtlCol="0" anchor="ctr"/>
+          <a:lstStyle/>
+          <a:p>
+            <a:pPr algn="ctr"/>
+          </a:p>
+        </p:txBody>
+      </p:sp>
+      <p:pic>
+        <p:nvPicPr>
+          <p:cNvPr id="31" name="Picture 30" descr="Illustration for Exercise 7"/>
+          <p:cNvPicPr>
+            <a:picLocks noChangeAspect="1"/>
+          </p:cNvPicPr>
+          <p:nvPr/>
+        </p:nvPicPr>
+        <p:blipFill>
+          <a:blip r:embed="rId5"/>
+          <a:stretch>
+            <a:fillRect/>
+          </a:stretch>
+        </p:blipFill>
+        <p:spPr>
+          <a:xfrm>
+            <a:off x="7190841" y="2112264"/>
+            <a:ext cx="621792" cy="621792"/>
+          </a:xfrm>
+          <a:prstGeom prst="rect">
+            <a:avLst/>
+          </a:prstGeom>
+        </p:spPr>
+      </p:pic>
+      <p:sp>
+        <p:nvSpPr>
+          <p:cNvPr id="32" name="Rounded Rectangle 31">
+            <a:extLst>
+              <a:ext uri="{C183D7F6-B498-43B3-948B-1728B52AA6E4}">
+                <ns12:decorative xmlns:ns12="http://schemas.microsoft.com/office/drawing/2017/decorative" val="1"/>
+              </a:ext>
+            </a:extLst>
+          </p:cNvPr>
+          <p:cNvSpPr/>
+          <p:nvPr/>
+        </p:nvSpPr>
+        <p:spPr>
+          <a:xfrm>
+            <a:off x="6313017" y="1920240"/>
+            <a:ext cx="866601" cy="246888"/>
+          </a:xfrm>
+          <a:prstGeom prst="roundRect">
+            <a:avLst>
+              <a:gd name="adj" fmla="val 50000"/>
+            </a:avLst>
+          </a:prstGeom>
+          <a:solidFill>
+            <a:srgbClr val="C0504D"/>
+          </a:solidFill>
+          <a:ln>
+            <a:noFill/>
+          </a:ln>
+          <a:effectLst/>
+        </p:spPr>
+        <p:style>
+          <a:lnRef idx="1">
+            <a:schemeClr val="accent1"/>
+          </a:lnRef>
+          <a:fillRef idx="3">
+            <a:schemeClr val="accent1"/>
+          </a:fillRef>
+          <a:effectRef idx="2">
+            <a:schemeClr val="accent1"/>
+          </a:effectRef>
+          <a:fontRef idx="minor">
+            <a:schemeClr val="lt1"/>
+          </a:fontRef>
+        </p:style>
+        <p:txBody>
+          <a:bodyPr rtlCol="0" anchor="ctr"/>
+          <a:lstStyle/>
+          <a:p>
+            <a:pPr algn="ctr"/>
+          </a:p>
+        </p:txBody>
+      </p:sp>
+      <p:sp>
+        <p:nvSpPr>
+          <p:cNvPr id="33" name="TextBox 32"/>
+          <p:cNvSpPr txBox="1"/>
+          <p:nvPr/>
+        </p:nvSpPr>
+        <p:spPr>
+          <a:xfrm>
+            <a:off x="6313017" y="1920240"/>
+            <a:ext cx="866601" cy="246888"/>
+          </a:xfrm>
+          <a:prstGeom prst="rect">
+            <a:avLst/>
+          </a:prstGeom>
+          <a:noFill/>
+        </p:spPr>
+        <p:txBody>
+          <a:bodyPr wrap="square" anchor="ctr" lIns="0" rIns="0" tIns="0" bIns="0">
+            <a:spAutoFit/>
+          </a:bodyPr>
+          <a:lstStyle/>
+          <a:p>
+            <a:pPr algn="ctr">
+              <a:spcAft>
+                <a:spcPts val="400"/>
+              </a:spcAft>
+            </a:pPr>
+            <a:r>
+              <a:rPr sz="950" b="0" i="0">
+                <a:solidFill>
+                  <a:srgbClr val="FFFFFF"/>
+                </a:solidFill>
+                <a:latin typeface="Segoe Sans Display Semibold"/>
+              </a:rPr>
+              <a:t>Not Cowork</a:t>
+            </a:r>
+          </a:p>
+        </p:txBody>
+      </p:sp>
+      <p:sp>
+        <p:nvSpPr>
+          <p:cNvPr id="34" name="TextBox 33"/>
+          <p:cNvSpPr txBox="1"/>
+          <p:nvPr/>
+        </p:nvSpPr>
+        <p:spPr>
+          <a:xfrm>
+            <a:off x="6358737" y="2990088"/>
+            <a:ext cx="2286000" cy="256032"/>
+          </a:xfrm>
+          <a:prstGeom prst="rect">
+            <a:avLst/>
+          </a:prstGeom>
+          <a:noFill/>
+        </p:spPr>
+        <p:txBody>
+          <a:bodyPr wrap="square" anchor="t" lIns="0" rIns="0" tIns="0" bIns="0">
+            <a:spAutoFit/>
+          </a:bodyPr>
+          <a:lstStyle/>
+          <a:p>
+            <a:pPr algn="ctr">
+              <a:spcAft>
+                <a:spcPts val="400"/>
+              </a:spcAft>
+            </a:pPr>
+            <a:r>
+              <a:rPr sz="1000" b="1" i="0">
+                <a:solidFill>
+                  <a:srgbClr val="8064A2"/>
+                </a:solidFill>
+                <a:latin typeface="Segoe UI"/>
+              </a:rPr>
+              <a:t>EXERCISE 7</a:t>
+            </a:r>
+          </a:p>
+        </p:txBody>
+      </p:sp>
+      <p:sp>
+        <p:nvSpPr>
+          <p:cNvPr id="35" name="TextBox 34"/>
+          <p:cNvSpPr txBox="1"/>
+          <p:nvPr/>
+        </p:nvSpPr>
+        <p:spPr>
+          <a:xfrm>
+            <a:off x="6358737" y="3227832"/>
+            <a:ext cx="2286000" cy="658368"/>
+          </a:xfrm>
+          <a:prstGeom prst="rect">
+            <a:avLst/>
+          </a:prstGeom>
+          <a:noFill/>
+        </p:spPr>
+        <p:txBody>
+          <a:bodyPr wrap="square" anchor="ctr" lIns="0" rIns="0" tIns="0" bIns="0">
+            <a:spAutoFit/>
+          </a:bodyPr>
+          <a:lstStyle/>
+          <a:p>
+            <a:pPr algn="ctr">
+              <a:lnSpc>
+                <a:spcPct val="95000"/>
+              </a:lnSpc>
+              <a:spcAft>
+                <a:spcPts val="400"/>
+              </a:spcAft>
+            </a:pPr>
+            <a:r>
+              <a:rPr sz="1450" b="1" i="0">
+                <a:solidFill>
+                  <a:srgbClr val="242424"/>
+                </a:solidFill>
+                <a:latin typeface="Segoe Sans Display Semibold"/>
+              </a:rPr>
+              <a:t>HR Policy Agent with Agent Builder</a:t>
+            </a:r>
+          </a:p>
+        </p:txBody>
+      </p:sp>
+      <p:sp>
+        <p:nvSpPr>
+          <p:cNvPr id="36" name="TextBox 35"/>
+          <p:cNvSpPr txBox="1"/>
+          <p:nvPr/>
+        </p:nvSpPr>
+        <p:spPr>
+          <a:xfrm>
+            <a:off x="6377025" y="3959352"/>
+            <a:ext cx="2249424" cy="1691640"/>
+          </a:xfrm>
+          <a:prstGeom prst="rect">
+            <a:avLst/>
+          </a:prstGeom>
+          <a:noFill/>
+        </p:spPr>
+        <p:txBody>
+          <a:bodyPr wrap="square" anchor="t" lIns="0" rIns="0" tIns="0" bIns="0">
+            <a:spAutoFit/>
+          </a:bodyPr>
+          <a:lstStyle/>
+          <a:p>
+            <a:pPr algn="l">
+              <a:lnSpc>
+                <a:spcPct val="102000"/>
+              </a:lnSpc>
+              <a:spcAft>
+                <a:spcPts val="600"/>
+              </a:spcAft>
+            </a:pPr>
+            <a:r>
+              <a:rPr sz="1150" b="0" i="0">
+                <a:solidFill>
+                  <a:srgbClr val="242424"/>
+                </a:solidFill>
+                <a:latin typeface="Segoe UI"/>
+              </a:rPr>
+              <a:t>Stand up a reusable Q&amp;A agent employees can chat with to get sourced policy answers.</a:t>
+            </a:r>
+          </a:p>
+          <a:p>
+            <a:pPr algn="l">
+              <a:lnSpc>
+                <a:spcPct val="102000"/>
+              </a:lnSpc>
+              <a:spcAft>
+                <a:spcPts val="600"/>
+              </a:spcAft>
+            </a:pPr>
+            <a:r>
+              <a:rPr sz="1000" b="1" i="0">
+                <a:solidFill>
+                  <a:srgbClr val="616161"/>
+                </a:solidFill>
+                <a:latin typeface="Segoe UI"/>
+              </a:rPr>
+              <a:t>Output:</a:t>
+            </a:r>
+            <a:r>
+              <a:rPr sz="1000" b="0" i="0">
+                <a:solidFill>
+                  <a:srgbClr val="616161"/>
+                </a:solidFill>
+                <a:latin typeface="Segoe UI"/>
+              </a:rPr>
+              <a:t> A working “HR Policy Agent” in Microsoft 365 Copilot, grounded in Zava’s HR documents, that cites sources and declines out-of-scope questions.</a:t>
+            </a:r>
+          </a:p>
+        </p:txBody>
+      </p:sp>
+      <p:sp>
+        <p:nvSpPr>
+          <p:cNvPr id="37" name="Rounded Rectangle 36">
+            <a:extLst>
+              <a:ext uri="{C183D7F6-B498-43B3-948B-1728B52AA6E4}">
+                <ns13:decorative xmlns:ns13="http://schemas.microsoft.com/office/drawing/2017/decorative" val="1"/>
+              </a:ext>
+            </a:extLst>
+          </p:cNvPr>
+          <p:cNvSpPr/>
+          <p:nvPr/>
+        </p:nvSpPr>
+        <p:spPr>
+          <a:xfrm>
+            <a:off x="6377025" y="5806440"/>
+            <a:ext cx="648392" cy="274320"/>
+          </a:xfrm>
+          <a:prstGeom prst="roundRect">
+            <a:avLst>
+              <a:gd name="adj" fmla="val 50000"/>
+            </a:avLst>
+          </a:prstGeom>
+          <a:solidFill>
+            <a:srgbClr val="F3E5FD"/>
+          </a:solidFill>
+          <a:ln>
+            <a:noFill/>
+          </a:ln>
+          <a:effectLst/>
+        </p:spPr>
+        <p:style>
+          <a:lnRef idx="1">
+            <a:schemeClr val="accent1"/>
+          </a:lnRef>
+          <a:fillRef idx="3">
+            <a:schemeClr val="accent1"/>
+          </a:fillRef>
+          <a:effectRef idx="2">
+            <a:schemeClr val="accent1"/>
+          </a:effectRef>
+          <a:fontRef idx="minor">
+            <a:schemeClr val="lt1"/>
+          </a:fontRef>
+        </p:style>
+        <p:txBody>
+          <a:bodyPr rtlCol="0" anchor="ctr"/>
+          <a:lstStyle/>
+          <a:p>
+            <a:pPr algn="ctr"/>
+          </a:p>
+        </p:txBody>
+      </p:sp>
+      <p:sp>
+        <p:nvSpPr>
+          <p:cNvPr id="38" name="TextBox 37"/>
+          <p:cNvSpPr txBox="1"/>
+          <p:nvPr/>
+        </p:nvSpPr>
+        <p:spPr>
+          <a:xfrm>
+            <a:off x="6377025" y="5806440"/>
+            <a:ext cx="648392" cy="274320"/>
+          </a:xfrm>
+          <a:prstGeom prst="rect">
+            <a:avLst/>
+          </a:prstGeom>
+          <a:noFill/>
+        </p:spPr>
+        <p:txBody>
+          <a:bodyPr wrap="square" anchor="ctr" lIns="0" rIns="0" tIns="0" bIns="0">
+            <a:spAutoFit/>
+          </a:bodyPr>
+          <a:lstStyle/>
+          <a:p>
+            <a:pPr algn="ctr">
+              <a:spcAft>
+                <a:spcPts val="400"/>
+              </a:spcAft>
+            </a:pPr>
+            <a:r>
+              <a:rPr sz="1000" b="0" i="0">
+                <a:solidFill>
+                  <a:srgbClr val="242424"/>
+                </a:solidFill>
+                <a:latin typeface="Segoe Sans Display Semibold"/>
+              </a:rPr>
+              <a:t>15 min</a:t>
+            </a:r>
+          </a:p>
+        </p:txBody>
+      </p:sp>
+      <p:sp>
+        <p:nvSpPr>
+          <p:cNvPr id="39" name="Rounded Rectangle 38">
+            <a:extLst>
+              <a:ext uri="{C183D7F6-B498-43B3-948B-1728B52AA6E4}">
+                <ns14:decorative xmlns:ns14="http://schemas.microsoft.com/office/drawing/2017/decorative" val="1"/>
+              </a:ext>
+            </a:extLst>
+          </p:cNvPr>
+          <p:cNvSpPr/>
+          <p:nvPr/>
+        </p:nvSpPr>
+        <p:spPr>
+          <a:xfrm>
+            <a:off x="7116858" y="5806440"/>
+            <a:ext cx="1084810" cy="274320"/>
+          </a:xfrm>
+          <a:prstGeom prst="roundRect">
+            <a:avLst>
+              <a:gd name="adj" fmla="val 50000"/>
+            </a:avLst>
+          </a:prstGeom>
+          <a:solidFill>
+            <a:srgbClr val="F3E5FD"/>
+          </a:solidFill>
+          <a:ln>
+            <a:noFill/>
+          </a:ln>
+          <a:effectLst/>
+        </p:spPr>
+        <p:style>
+          <a:lnRef idx="1">
+            <a:schemeClr val="accent1"/>
+          </a:lnRef>
+          <a:fillRef idx="3">
+            <a:schemeClr val="accent1"/>
+          </a:fillRef>
+          <a:effectRef idx="2">
+            <a:schemeClr val="accent1"/>
+          </a:effectRef>
+          <a:fontRef idx="minor">
+            <a:schemeClr val="lt1"/>
+          </a:fontRef>
+        </p:style>
+        <p:txBody>
+          <a:bodyPr rtlCol="0" anchor="ctr"/>
+          <a:lstStyle/>
+          <a:p>
+            <a:pPr algn="ctr"/>
+          </a:p>
+        </p:txBody>
+      </p:sp>
+      <p:sp>
+        <p:nvSpPr>
+          <p:cNvPr id="40" name="TextBox 39"/>
+          <p:cNvSpPr txBox="1"/>
+          <p:nvPr/>
+        </p:nvSpPr>
+        <p:spPr>
+          <a:xfrm>
+            <a:off x="7116858" y="5806440"/>
+            <a:ext cx="1084810" cy="274320"/>
+          </a:xfrm>
+          <a:prstGeom prst="rect">
+            <a:avLst/>
+          </a:prstGeom>
+          <a:noFill/>
+        </p:spPr>
+        <p:txBody>
+          <a:bodyPr wrap="square" anchor="ctr" lIns="0" rIns="0" tIns="0" bIns="0">
+            <a:spAutoFit/>
+          </a:bodyPr>
+          <a:lstStyle/>
+          <a:p>
+            <a:pPr algn="ctr">
+              <a:spcAft>
+                <a:spcPts val="400"/>
+              </a:spcAft>
+            </a:pPr>
+            <a:r>
+              <a:rPr sz="1000" b="0" i="0">
+                <a:solidFill>
+                  <a:srgbClr val="242424"/>
+                </a:solidFill>
+                <a:latin typeface="Segoe Sans Display Semibold"/>
+              </a:rPr>
+              <a:t>Agent Builder</a:t>
+            </a:r>
+          </a:p>
+        </p:txBody>
+      </p:sp>
+      <p:sp>
+        <p:nvSpPr>
+          <p:cNvPr id="41" name="Rounded Rectangle 40">
+            <a:extLst>
+              <a:ext uri="{C183D7F6-B498-43B3-948B-1728B52AA6E4}">
+                <ns15:decorative xmlns:ns15="http://schemas.microsoft.com/office/drawing/2017/decorative" val="1"/>
+              </a:ext>
+            </a:extLst>
+          </p:cNvPr>
+          <p:cNvSpPr/>
+          <p:nvPr/>
+        </p:nvSpPr>
+        <p:spPr>
+          <a:xfrm>
+            <a:off x="8989466" y="1783080"/>
             <a:ext cx="2651760" cy="4480560"/>
           </a:xfrm>
           <a:prstGeom prst="roundRect">
@@ -25680,10 +26252,10 @@
       </p:sp>
       <p:sp>
         <p:nvSpPr>
-          <p:cNvPr id="30" name="Oval 29">
+          <p:cNvPr id="42" name="Oval 41">
             <a:extLst>
               <a:ext uri="{C183D7F6-B498-43B3-948B-1728B52AA6E4}">
-                <ns11:decorative xmlns:ns11="http://schemas.microsoft.com/office/drawing/2017/decorative" val="1"/>
+                <ns16:decorative xmlns:ns16="http://schemas.microsoft.com/office/drawing/2017/decorative" val="1"/>
               </a:ext>
             </a:extLst>
           </p:cNvPr>
@@ -25692,7 +26264,7 @@
         </p:nvSpPr>
         <p:spPr>
           <a:xfrm>
-            <a:off x="7044537" y="1965960"/>
+            <a:off x="9858146" y="1965960"/>
             <a:ext cx="914400" cy="914400"/>
           </a:xfrm>
           <a:prstGeom prst="ellipse">
@@ -25732,470 +26304,7 @@
       </p:sp>
       <p:pic>
         <p:nvPicPr>
-          <p:cNvPr id="31" name="Picture 30" descr="Illustration for Exercise 7"/>
-          <p:cNvPicPr>
-            <a:picLocks noChangeAspect="1"/>
-          </p:cNvPicPr>
-          <p:nvPr/>
-        </p:nvPicPr>
-        <p:blipFill>
-          <a:blip r:embed="rId5"/>
-          <a:stretch>
-            <a:fillRect/>
-          </a:stretch>
-        </p:blipFill>
-        <p:spPr>
-          <a:xfrm>
-            <a:off x="7190841" y="2112264"/>
-            <a:ext cx="621792" cy="621792"/>
-          </a:xfrm>
-          <a:prstGeom prst="rect">
-            <a:avLst/>
-          </a:prstGeom>
-        </p:spPr>
-      </p:pic>
-      <p:sp>
-        <p:nvSpPr>
-          <p:cNvPr id="32" name="TextBox 31"/>
-          <p:cNvSpPr txBox="1"/>
-          <p:nvPr/>
-        </p:nvSpPr>
-        <p:spPr>
-          <a:xfrm>
-            <a:off x="6358737" y="2990088"/>
-            <a:ext cx="2286000" cy="256032"/>
-          </a:xfrm>
-          <a:prstGeom prst="rect">
-            <a:avLst/>
-          </a:prstGeom>
-          <a:noFill/>
-        </p:spPr>
-        <p:txBody>
-          <a:bodyPr wrap="square" anchor="t" lIns="0" rIns="0" tIns="0" bIns="0">
-            <a:spAutoFit/>
-          </a:bodyPr>
-          <a:lstStyle/>
-          <a:p>
-            <a:pPr algn="ctr">
-              <a:spcAft>
-                <a:spcPts val="400"/>
-              </a:spcAft>
-            </a:pPr>
-            <a:r>
-              <a:rPr sz="1000" b="1" i="0">
-                <a:solidFill>
-                  <a:srgbClr val="8064A2"/>
-                </a:solidFill>
-                <a:latin typeface="Segoe UI"/>
-              </a:rPr>
-              <a:t>EXERCISE 7</a:t>
-            </a:r>
-          </a:p>
-        </p:txBody>
-      </p:sp>
-      <p:sp>
-        <p:nvSpPr>
-          <p:cNvPr id="33" name="TextBox 32"/>
-          <p:cNvSpPr txBox="1"/>
-          <p:nvPr/>
-        </p:nvSpPr>
-        <p:spPr>
-          <a:xfrm>
-            <a:off x="6358737" y="3227832"/>
-            <a:ext cx="2286000" cy="658368"/>
-          </a:xfrm>
-          <a:prstGeom prst="rect">
-            <a:avLst/>
-          </a:prstGeom>
-          <a:noFill/>
-        </p:spPr>
-        <p:txBody>
-          <a:bodyPr wrap="square" anchor="ctr" lIns="0" rIns="0" tIns="0" bIns="0">
-            <a:spAutoFit/>
-          </a:bodyPr>
-          <a:lstStyle/>
-          <a:p>
-            <a:pPr algn="ctr">
-              <a:lnSpc>
-                <a:spcPct val="95000"/>
-              </a:lnSpc>
-              <a:spcAft>
-                <a:spcPts val="400"/>
-              </a:spcAft>
-            </a:pPr>
-            <a:r>
-              <a:rPr sz="1450" b="1" i="0">
-                <a:solidFill>
-                  <a:srgbClr val="242424"/>
-                </a:solidFill>
-                <a:latin typeface="Segoe Sans Display Semibold"/>
-              </a:rPr>
-              <a:t>Automate &amp; Share</a:t>
-            </a:r>
-          </a:p>
-        </p:txBody>
-      </p:sp>
-      <p:sp>
-        <p:nvSpPr>
-          <p:cNvPr id="34" name="TextBox 33"/>
-          <p:cNvSpPr txBox="1"/>
-          <p:nvPr/>
-        </p:nvSpPr>
-        <p:spPr>
-          <a:xfrm>
-            <a:off x="6377025" y="3959352"/>
-            <a:ext cx="2249424" cy="1691640"/>
-          </a:xfrm>
-          <a:prstGeom prst="rect">
-            <a:avLst/>
-          </a:prstGeom>
-          <a:noFill/>
-        </p:spPr>
-        <p:txBody>
-          <a:bodyPr wrap="square" anchor="t" lIns="0" rIns="0" tIns="0" bIns="0">
-            <a:spAutoFit/>
-          </a:bodyPr>
-          <a:lstStyle/>
-          <a:p>
-            <a:pPr algn="l">
-              <a:lnSpc>
-                <a:spcPct val="102000"/>
-              </a:lnSpc>
-              <a:spcAft>
-                <a:spcPts val="600"/>
-              </a:spcAft>
-            </a:pPr>
-            <a:r>
-              <a:rPr sz="1150" b="0" i="0">
-                <a:solidFill>
-                  <a:srgbClr val="242424"/>
-                </a:solidFill>
-                <a:latin typeface="Segoe UI"/>
-              </a:rPr>
-              <a:t>Stop re-asking for the same work — put it on a schedule and share what you built.</a:t>
-            </a:r>
-          </a:p>
-          <a:p>
-            <a:pPr algn="l">
-              <a:lnSpc>
-                <a:spcPct val="102000"/>
-              </a:lnSpc>
-              <a:spcAft>
-                <a:spcPts val="600"/>
-              </a:spcAft>
-            </a:pPr>
-            <a:r>
-              <a:rPr sz="1000" b="1" i="0">
-                <a:solidFill>
-                  <a:srgbClr val="616161"/>
-                </a:solidFill>
-                <a:latin typeface="Segoe UI"/>
-              </a:rPr>
-              <a:t>Output:</a:t>
-            </a:r>
-            <a:r>
-              <a:rPr sz="1000" b="0" i="0">
-                <a:solidFill>
-                  <a:srgbClr val="616161"/>
-                </a:solidFill>
-                <a:latin typeface="Segoe UI"/>
-              </a:rPr>
-              <a:t> An active weekly automation (Monday HR-ticket digest) and a Daily Briefing; if time allows, your custom skill shared (or kept private) and re-shared after an edit.</a:t>
-            </a:r>
-          </a:p>
-        </p:txBody>
-      </p:sp>
-      <p:sp>
-        <p:nvSpPr>
-          <p:cNvPr id="35" name="Rounded Rectangle 34">
-            <a:extLst>
-              <a:ext uri="{C183D7F6-B498-43B3-948B-1728B52AA6E4}">
-                <ns12:decorative xmlns:ns12="http://schemas.microsoft.com/office/drawing/2017/decorative" val="1"/>
-              </a:ext>
-            </a:extLst>
-          </p:cNvPr>
-          <p:cNvSpPr/>
-          <p:nvPr/>
-        </p:nvSpPr>
-        <p:spPr>
-          <a:xfrm>
-            <a:off x="6377025" y="5806440"/>
-            <a:ext cx="648392" cy="274320"/>
-          </a:xfrm>
-          <a:prstGeom prst="roundRect">
-            <a:avLst>
-              <a:gd name="adj" fmla="val 50000"/>
-            </a:avLst>
-          </a:prstGeom>
-          <a:solidFill>
-            <a:srgbClr val="F3E5FD"/>
-          </a:solidFill>
-          <a:ln>
-            <a:noFill/>
-          </a:ln>
-          <a:effectLst/>
-        </p:spPr>
-        <p:style>
-          <a:lnRef idx="1">
-            <a:schemeClr val="accent1"/>
-          </a:lnRef>
-          <a:fillRef idx="3">
-            <a:schemeClr val="accent1"/>
-          </a:fillRef>
-          <a:effectRef idx="2">
-            <a:schemeClr val="accent1"/>
-          </a:effectRef>
-          <a:fontRef idx="minor">
-            <a:schemeClr val="lt1"/>
-          </a:fontRef>
-        </p:style>
-        <p:txBody>
-          <a:bodyPr rtlCol="0" anchor="ctr"/>
-          <a:lstStyle/>
-          <a:p>
-            <a:pPr algn="ctr"/>
-          </a:p>
-        </p:txBody>
-      </p:sp>
-      <p:sp>
-        <p:nvSpPr>
-          <p:cNvPr id="36" name="TextBox 35"/>
-          <p:cNvSpPr txBox="1"/>
-          <p:nvPr/>
-        </p:nvSpPr>
-        <p:spPr>
-          <a:xfrm>
-            <a:off x="6377025" y="5806440"/>
-            <a:ext cx="648392" cy="274320"/>
-          </a:xfrm>
-          <a:prstGeom prst="rect">
-            <a:avLst/>
-          </a:prstGeom>
-          <a:noFill/>
-        </p:spPr>
-        <p:txBody>
-          <a:bodyPr wrap="square" anchor="ctr" lIns="0" rIns="0" tIns="0" bIns="0">
-            <a:spAutoFit/>
-          </a:bodyPr>
-          <a:lstStyle/>
-          <a:p>
-            <a:pPr algn="ctr">
-              <a:spcAft>
-                <a:spcPts val="400"/>
-              </a:spcAft>
-            </a:pPr>
-            <a:r>
-              <a:rPr sz="1000" b="0" i="0">
-                <a:solidFill>
-                  <a:srgbClr val="242424"/>
-                </a:solidFill>
-                <a:latin typeface="Segoe Sans Display Semibold"/>
-              </a:rPr>
-              <a:t>15 min</a:t>
-            </a:r>
-          </a:p>
-        </p:txBody>
-      </p:sp>
-      <p:sp>
-        <p:nvSpPr>
-          <p:cNvPr id="37" name="Rounded Rectangle 36">
-            <a:extLst>
-              <a:ext uri="{C183D7F6-B498-43B3-948B-1728B52AA6E4}">
-                <ns13:decorative xmlns:ns13="http://schemas.microsoft.com/office/drawing/2017/decorative" val="1"/>
-              </a:ext>
-            </a:extLst>
-          </p:cNvPr>
-          <p:cNvSpPr/>
-          <p:nvPr/>
-        </p:nvSpPr>
-        <p:spPr>
-          <a:xfrm>
-            <a:off x="7116858" y="5806440"/>
-            <a:ext cx="1209501" cy="274320"/>
-          </a:xfrm>
-          <a:prstGeom prst="roundRect">
-            <a:avLst>
-              <a:gd name="adj" fmla="val 50000"/>
-            </a:avLst>
-          </a:prstGeom>
-          <a:solidFill>
-            <a:srgbClr val="F3E5FD"/>
-          </a:solidFill>
-          <a:ln>
-            <a:noFill/>
-          </a:ln>
-          <a:effectLst/>
-        </p:spPr>
-        <p:style>
-          <a:lnRef idx="1">
-            <a:schemeClr val="accent1"/>
-          </a:lnRef>
-          <a:fillRef idx="3">
-            <a:schemeClr val="accent1"/>
-          </a:fillRef>
-          <a:effectRef idx="2">
-            <a:schemeClr val="accent1"/>
-          </a:effectRef>
-          <a:fontRef idx="minor">
-            <a:schemeClr val="lt1"/>
-          </a:fontRef>
-        </p:style>
-        <p:txBody>
-          <a:bodyPr rtlCol="0" anchor="ctr"/>
-          <a:lstStyle/>
-          <a:p>
-            <a:pPr algn="ctr"/>
-          </a:p>
-        </p:txBody>
-      </p:sp>
-      <p:sp>
-        <p:nvSpPr>
-          <p:cNvPr id="38" name="TextBox 37"/>
-          <p:cNvSpPr txBox="1"/>
-          <p:nvPr/>
-        </p:nvSpPr>
-        <p:spPr>
-          <a:xfrm>
-            <a:off x="7116858" y="5806440"/>
-            <a:ext cx="1209501" cy="274320"/>
-          </a:xfrm>
-          <a:prstGeom prst="rect">
-            <a:avLst/>
-          </a:prstGeom>
-          <a:noFill/>
-        </p:spPr>
-        <p:txBody>
-          <a:bodyPr wrap="square" anchor="ctr" lIns="0" rIns="0" tIns="0" bIns="0">
-            <a:spAutoFit/>
-          </a:bodyPr>
-          <a:lstStyle/>
-          <a:p>
-            <a:pPr algn="ctr">
-              <a:spcAft>
-                <a:spcPts val="400"/>
-              </a:spcAft>
-            </a:pPr>
-            <a:r>
-              <a:rPr sz="1000" b="0" i="0">
-                <a:solidFill>
-                  <a:srgbClr val="242424"/>
-                </a:solidFill>
-                <a:latin typeface="Segoe Sans Display Semibold"/>
-              </a:rPr>
-              <a:t>HR · Operations</a:t>
-            </a:r>
-          </a:p>
-        </p:txBody>
-      </p:sp>
-      <p:sp>
-        <p:nvSpPr>
-          <p:cNvPr id="39" name="Rounded Rectangle 38">
-            <a:extLst>
-              <a:ext uri="{C183D7F6-B498-43B3-948B-1728B52AA6E4}">
-                <ns14:decorative xmlns:ns14="http://schemas.microsoft.com/office/drawing/2017/decorative" val="1"/>
-              </a:ext>
-            </a:extLst>
-          </p:cNvPr>
-          <p:cNvSpPr/>
-          <p:nvPr/>
-        </p:nvSpPr>
-        <p:spPr>
-          <a:xfrm>
-            <a:off x="8989466" y="1783080"/>
-            <a:ext cx="2651760" cy="4480560"/>
-          </a:xfrm>
-          <a:prstGeom prst="roundRect">
-            <a:avLst>
-              <a:gd name="adj" fmla="val 5000"/>
-            </a:avLst>
-          </a:prstGeom>
-          <a:solidFill>
-            <a:srgbClr val="FFFFFF"/>
-          </a:solidFill>
-          <a:ln w="9525">
-            <a:solidFill>
-              <a:srgbClr val="C0504D"/>
-            </a:solidFill>
-          </a:ln>
-          <a:effectLst/>
-        </p:spPr>
-        <p:style>
-          <a:lnRef idx="1">
-            <a:schemeClr val="accent1"/>
-          </a:lnRef>
-          <a:fillRef idx="3">
-            <a:schemeClr val="accent1"/>
-          </a:fillRef>
-          <a:effectRef idx="2">
-            <a:schemeClr val="accent1"/>
-          </a:effectRef>
-          <a:fontRef idx="minor">
-            <a:schemeClr val="lt1"/>
-          </a:fontRef>
-        </p:style>
-        <p:txBody>
-          <a:bodyPr rtlCol="0" anchor="ctr"/>
-          <a:lstStyle/>
-          <a:p>
-            <a:pPr algn="ctr"/>
-          </a:p>
-        </p:txBody>
-      </p:sp>
-      <p:sp>
-        <p:nvSpPr>
-          <p:cNvPr id="40" name="Oval 39">
-            <a:extLst>
-              <a:ext uri="{C183D7F6-B498-43B3-948B-1728B52AA6E4}">
-                <ns15:decorative xmlns:ns15="http://schemas.microsoft.com/office/drawing/2017/decorative" val="1"/>
-              </a:ext>
-            </a:extLst>
-          </p:cNvPr>
-          <p:cNvSpPr/>
-          <p:nvPr/>
-        </p:nvSpPr>
-        <p:spPr>
-          <a:xfrm>
-            <a:off x="9858146" y="1965960"/>
-            <a:ext cx="914400" cy="914400"/>
-          </a:xfrm>
-          <a:prstGeom prst="ellipse">
-            <a:avLst/>
-          </a:prstGeom>
-          <a:solidFill>
-            <a:srgbClr val="FFF9FD"/>
-          </a:solidFill>
-          <a:ln w="9525">
-            <a:solidFill>
-              <a:srgbClr val="D1D1D1"/>
-            </a:solidFill>
-          </a:ln>
-          <a:effectLst/>
-        </p:spPr>
-        <p:style>
-          <a:lnRef idx="1">
-            <a:schemeClr val="accent1"/>
-          </a:lnRef>
-          <a:fillRef idx="3">
-            <a:schemeClr val="accent1"/>
-          </a:fillRef>
-          <a:effectRef idx="2">
-            <a:schemeClr val="accent1"/>
-          </a:effectRef>
-          <a:fontRef idx="minor">
-            <a:schemeClr val="lt1"/>
-          </a:fontRef>
-        </p:style>
-        <p:txBody>
-          <a:bodyPr rtlCol="0" anchor="ctr"/>
-          <a:lstStyle/>
-          <a:p>
-            <a:pPr algn="ctr"/>
-          </a:p>
-        </p:txBody>
-      </p:sp>
-      <p:pic>
-        <p:nvPicPr>
-          <p:cNvPr id="41" name="Picture 40" descr="Illustration for Exercise 8"/>
+          <p:cNvPr id="43" name="Picture 42" descr="Illustration for Exercise 8"/>
           <p:cNvPicPr>
             <a:picLocks noChangeAspect="1"/>
           </p:cNvPicPr>
@@ -26219,97 +26328,6 @@
       </p:pic>
       <p:sp>
         <p:nvSpPr>
-          <p:cNvPr id="42" name="Rounded Rectangle 41">
-            <a:extLst>
-              <a:ext uri="{C183D7F6-B498-43B3-948B-1728B52AA6E4}">
-                <ns16:decorative xmlns:ns16="http://schemas.microsoft.com/office/drawing/2017/decorative" val="1"/>
-              </a:ext>
-            </a:extLst>
-          </p:cNvPr>
-          <p:cNvSpPr/>
-          <p:nvPr/>
-        </p:nvSpPr>
-        <p:spPr>
-          <a:xfrm>
-            <a:off x="9126626" y="1920240"/>
-            <a:ext cx="866601" cy="246888"/>
-          </a:xfrm>
-          <a:prstGeom prst="roundRect">
-            <a:avLst>
-              <a:gd name="adj" fmla="val 50000"/>
-            </a:avLst>
-          </a:prstGeom>
-          <a:solidFill>
-            <a:srgbClr val="C0504D"/>
-          </a:solidFill>
-          <a:ln>
-            <a:noFill/>
-          </a:ln>
-          <a:effectLst/>
-        </p:spPr>
-        <p:style>
-          <a:lnRef idx="1">
-            <a:schemeClr val="accent1"/>
-          </a:lnRef>
-          <a:fillRef idx="3">
-            <a:schemeClr val="accent1"/>
-          </a:fillRef>
-          <a:effectRef idx="2">
-            <a:schemeClr val="accent1"/>
-          </a:effectRef>
-          <a:fontRef idx="minor">
-            <a:schemeClr val="lt1"/>
-          </a:fontRef>
-        </p:style>
-        <p:txBody>
-          <a:bodyPr rtlCol="0" anchor="ctr"/>
-          <a:lstStyle/>
-          <a:p>
-            <a:pPr algn="ctr"/>
-          </a:p>
-        </p:txBody>
-      </p:sp>
-      <p:sp>
-        <p:nvSpPr>
-          <p:cNvPr id="43" name="TextBox 42"/>
-          <p:cNvSpPr txBox="1"/>
-          <p:nvPr/>
-        </p:nvSpPr>
-        <p:spPr>
-          <a:xfrm>
-            <a:off x="9126626" y="1920240"/>
-            <a:ext cx="866601" cy="246888"/>
-          </a:xfrm>
-          <a:prstGeom prst="rect">
-            <a:avLst/>
-          </a:prstGeom>
-          <a:noFill/>
-        </p:spPr>
-        <p:txBody>
-          <a:bodyPr wrap="square" anchor="ctr" lIns="0" rIns="0" tIns="0" bIns="0">
-            <a:spAutoFit/>
-          </a:bodyPr>
-          <a:lstStyle/>
-          <a:p>
-            <a:pPr algn="ctr">
-              <a:spcAft>
-                <a:spcPts val="400"/>
-              </a:spcAft>
-            </a:pPr>
-            <a:r>
-              <a:rPr sz="950" b="0" i="0">
-                <a:solidFill>
-                  <a:srgbClr val="FFFFFF"/>
-                </a:solidFill>
-                <a:latin typeface="Segoe Sans Display Semibold"/>
-              </a:rPr>
-              <a:t>Not Cowork</a:t>
-            </a:r>
-          </a:p>
-        </p:txBody>
-      </p:sp>
-      <p:sp>
-        <p:nvSpPr>
           <p:cNvPr id="44" name="TextBox 43"/>
           <p:cNvSpPr txBox="1"/>
           <p:nvPr/>
@@ -26384,7 +26402,7 @@
                 </a:solidFill>
                 <a:latin typeface="Segoe Sans Display Semibold"/>
               </a:rPr>
-              <a:t>HR Policy Agent with Agent Builder</a:t>
+              <a:t>Executive Command Center</a:t>
             </a:r>
           </a:p>
         </p:txBody>
@@ -26426,7 +26444,7 @@
                 </a:solidFill>
                 <a:latin typeface="Segoe UI"/>
               </a:rPr>
-              <a:t>Stand up a reusable Q&amp;A agent employees can chat with to get sourced policy answers.</a:t>
+              <a:t>Turn your calendar, communications, and priority work into a daily executive view of decisions, risks, and actions requiring attention.</a:t>
             </a:r>
           </a:p>
           <a:p>
@@ -26454,7 +26472,7 @@
                 </a:solidFill>
                 <a:latin typeface="Segoe UI"/>
               </a:rPr>
-              <a:t> A working “HR Policy Agent” in Microsoft 365 Copilot, grounded in Zava’s HR documents, that cites sources and declines out-of-scope questions.</a:t>
+              <a:t> An interactive executive command center covering meetings, priorities, and org pulse, with labeled recommendations and links to supporting context.</a:t>
             </a:r>
           </a:p>
         </p:txBody>
@@ -26565,7 +26583,7 @@
         <p:spPr>
           <a:xfrm>
             <a:off x="9930467" y="5806440"/>
-            <a:ext cx="1084810" cy="274320"/>
+            <a:ext cx="835429" cy="274320"/>
           </a:xfrm>
           <a:prstGeom prst="roundRect">
             <a:avLst>
@@ -26611,7 +26629,7 @@
         <p:spPr>
           <a:xfrm>
             <a:off x="9930467" y="5806440"/>
-            <a:ext cx="1084810" cy="274320"/>
+            <a:ext cx="835429" cy="274320"/>
           </a:xfrm>
           <a:prstGeom prst="rect">
             <a:avLst/>
@@ -26636,7 +26654,7 @@
                 </a:solidFill>
                 <a:latin typeface="Segoe Sans Display Semibold"/>
               </a:rPr>
-              <a:t>Agent Builder</a:t>
+              <a:t>Executive</a:t>
             </a:r>
           </a:p>
         </p:txBody>

</xml_diff>

<commit_message>
Move reference slides to optional sections and extend Exercise 4
Group workshop downloads, approval guidance, and golden rules after Exercise 8. Give Exercise 4 fifteen minutes, shift later timings, and update decks, Word guides, and invitations for the 155-minute workshop.

Co-authored-by: Copilot <223556219+Copilot@users.noreply.github.com>
</commit_message>
<xml_diff>
--- a/instructor/customer-preview-deck.pptx
+++ b/instructor/customer-preview-deck.pptx
@@ -938,7 +938,7 @@
           <a:lstStyle/>
           <a:p>
             <a:r>
-              <a:t>TAILORING. Note any choices on the capture slide. Swapping exercises keeps the 150-minute length; adding content means dropping something else.</a:t>
+              <a:t>TAILORING. Note any choices on the capture slide. Swapping exercises keeps the 155-minute length; adding content means dropping something else.</a:t>
             </a:r>
           </a:p>
         </p:txBody>
@@ -1428,7 +1428,7 @@
           <a:lstStyle/>
           <a:p>
             <a:r>
-              <a:t>AGENDA. Ask: does one 150-minute session work, or would two shorter sessions fit your calendar better? Any hard stop times?</a:t>
+              <a:t>AGENDA. Ask: does one 155-minute session work, or would two shorter sessions fit your calendar better? Any hard stop times?</a:t>
             </a:r>
           </a:p>
         </p:txBody>
@@ -4835,7 +4835,7 @@
                 </a:solidFill>
                 <a:latin typeface="Segoe Sans Display"/>
               </a:rPr>
-              <a:t>A 2½-hour, hands-on, no-code workshop that helps HR teams hand everyday work to Microsoft Copilot Cowork</a:t>
+              <a:t>A 2-hour 35-minute, hands-on, no-code workshop that helps HR teams hand everyday work to Microsoft Copilot Cowork</a:t>
             </a:r>
           </a:p>
         </p:txBody>
@@ -11580,7 +11580,7 @@
                 </a:solidFill>
                 <a:latin typeface="Segoe UI"/>
               </a:rPr>
-              <a:t>One 150-minute session, or two shorter ones? In person or remote?</a:t>
+              <a:t>One 155-minute session, or two shorter ones? In person or remote?</a:t>
             </a:r>
           </a:p>
           <a:p>
@@ -15061,7 +15061,7 @@
                 </a:solidFill>
                 <a:latin typeface="Segoe UI"/>
               </a:rPr>
-              <a:t>150 minutes, hands-on</a:t>
+              <a:t>155 minutes, hands-on</a:t>
             </a:r>
           </a:p>
         </p:txBody>
@@ -16707,7 +16707,7 @@
                 </a:solidFill>
                 <a:latin typeface="Segoe Sans Display"/>
               </a:rPr>
-              <a:t>2½ hours</a:t>
+              <a:t>155 min</a:t>
             </a:r>
           </a:p>
         </p:txBody>
@@ -20621,7 +20621,7 @@
                 </a:solidFill>
                 <a:latin typeface="Segoe Sans Display"/>
               </a:rPr>
-              <a:t>Agenda · 150 minutes</a:t>
+              <a:t>Agenda · 155 minutes</a:t>
             </a:r>
           </a:p>
         </p:txBody>
@@ -21450,7 +21450,7 @@
                 </a:solidFill>
                 <a:latin typeface="Segoe Sans Display Semibold"/>
               </a:rPr>
-              <a:t>1:05–1:15</a:t>
+              <a:t>1:05–1:20</a:t>
             </a:r>
           </a:p>
         </p:txBody>
@@ -21582,7 +21582,7 @@
                 </a:solidFill>
                 <a:latin typeface="Segoe Sans Display Semibold"/>
               </a:rPr>
-              <a:t>1:15–1:30</a:t>
+              <a:t>1:20–1:35</a:t>
             </a:r>
           </a:p>
         </p:txBody>
@@ -21714,7 +21714,7 @@
                 </a:solidFill>
                 <a:latin typeface="Segoe Sans Display Semibold"/>
               </a:rPr>
-              <a:t>1:30–1:40</a:t>
+              <a:t>1:35–1:45</a:t>
             </a:r>
           </a:p>
         </p:txBody>
@@ -21846,7 +21846,7 @@
                 </a:solidFill>
                 <a:latin typeface="Segoe Sans Display Semibold"/>
               </a:rPr>
-              <a:t>1:40–1:55</a:t>
+              <a:t>1:45–2:00</a:t>
             </a:r>
           </a:p>
         </p:txBody>
@@ -21978,7 +21978,7 @@
                 </a:solidFill>
                 <a:latin typeface="Segoe Sans Display Semibold"/>
               </a:rPr>
-              <a:t>1:55–2:10</a:t>
+              <a:t>2:00–2:15</a:t>
             </a:r>
           </a:p>
         </p:txBody>
@@ -22110,7 +22110,7 @@
                 </a:solidFill>
                 <a:latin typeface="Segoe Sans Display Semibold"/>
               </a:rPr>
-              <a:t>2:10–2:25</a:t>
+              <a:t>2:15–2:30</a:t>
             </a:r>
           </a:p>
         </p:txBody>
@@ -22242,7 +22242,7 @@
                 </a:solidFill>
                 <a:latin typeface="Segoe Sans Display Semibold"/>
               </a:rPr>
-              <a:t>2:25–2:30</a:t>
+              <a:t>2:30–2:35</a:t>
             </a:r>
           </a:p>
         </p:txBody>
@@ -24331,7 +24331,7 @@
                 </a:solidFill>
                 <a:latin typeface="Segoe Sans Display Semibold"/>
               </a:rPr>
-              <a:t>10 min</a:t>
+              <a:t>15 min</a:t>
             </a:r>
           </a:p>
         </p:txBody>

</xml_diff>

<commit_message>
Add Prompt Coach slide and simplify deck duration labels
Show how to find Prompt Coach and use it to improve a weak prompt with review and data-safety guidance. Update instructor, overview, and preview decks to describe the workshop as about three hours.

Co-authored-by: Copilot <223556219+Copilot@users.noreply.github.com>
</commit_message>
<xml_diff>
--- a/instructor/customer-preview-deck.pptx
+++ b/instructor/customer-preview-deck.pptx
@@ -4835,7 +4835,7 @@
                 </a:solidFill>
                 <a:latin typeface="Segoe Sans Display"/>
               </a:rPr>
-              <a:t>A 2-hour 35-minute, hands-on, no-code workshop that helps HR teams hand everyday work to Microsoft Copilot Cowork</a:t>
+              <a:t>An about-3-hour, hands-on, no-code workshop that helps HR teams hand everyday work to Microsoft Copilot Cowork</a:t>
             </a:r>
           </a:p>
         </p:txBody>
@@ -15061,7 +15061,7 @@
                 </a:solidFill>
                 <a:latin typeface="Segoe UI"/>
               </a:rPr>
-              <a:t>155 minutes, hands-on</a:t>
+              <a:t>About 3 hours, hands-on</a:t>
             </a:r>
           </a:p>
         </p:txBody>
@@ -16707,7 +16707,7 @@
                 </a:solidFill>
                 <a:latin typeface="Segoe Sans Display"/>
               </a:rPr>
-              <a:t>155 min</a:t>
+              <a:t>About 3 hours</a:t>
             </a:r>
           </a:p>
         </p:txBody>
@@ -20621,7 +20621,7 @@
                 </a:solidFill>
                 <a:latin typeface="Segoe Sans Display"/>
               </a:rPr>
-              <a:t>Agenda · 155 minutes</a:t>
+              <a:t>Agenda · About 3 hours</a:t>
             </a:r>
           </a:p>
         </p:txBody>

</xml_diff>